<commit_message>
Verify campus workflow and promote first scanned release with isolated dashboard guidance
</commit_message>
<xml_diff>
--- a/demo/presentation.pptx
+++ b/demo/presentation.pptx
@@ -3388,7 +3388,7 @@
               </a:defRPr>
             </a:pPr>
             <a:r>
-              <a:t>Built for the DevSecOps assignment. Temporary AWS resources are removed after evidence capture.</a:t>
+              <a:t>Prepared for Aryan (AJ5831A). Shared ResolveDesk foundation is credited; campus fields add a distinct workflow.</a:t>
             </a:r>
           </a:p>
         </p:txBody>
@@ -3774,7 +3774,7 @@
               </a:defRPr>
             </a:pPr>
             <a:r>
-              <a:t>Runtime evidence: see demo/evidence and the final walkthrough for the recorded deployment state.</a:t>
+              <a:t>Local PostgreSQL CRUD and restart persistence passed. Cloud runtime evidence is recorded separately.</a:t>
             </a:r>
           </a:p>
         </p:txBody>

</xml_diff>

<commit_message>
Record shared infrastructure recovery and prepare reproducible campus walkthrough
</commit_message>
<xml_diff>
--- a/demo/presentation.pptx
+++ b/demo/presentation.pptx
@@ -3424,7 +3424,7 @@
               </a:defRPr>
             </a:pPr>
             <a:r>
-              <a:t>RESOLVEDESK  /  DEVSECOPS PROJECT</a:t>
+              <a:t>CAMPUSDESK  /  DEVSECOPS PROJECT</a:t>
             </a:r>
           </a:p>
         </p:txBody>
@@ -3954,7 +3954,7 @@
               </a:defRPr>
             </a:pPr>
             <a:r>
-              <a:t>RESOLVEDESK  /  DEVSECOPS PROJECT</a:t>
+              <a:t>CAMPUSDESK  /  DEVSECOPS PROJECT</a:t>
             </a:r>
           </a:p>
         </p:txBody>
@@ -4412,7 +4412,7 @@
               </a:defRPr>
             </a:pPr>
             <a:r>
-              <a:t>RESOLVEDESK  /  DEVSECOPS PROJECT</a:t>
+              <a:t>CAMPUSDESK  /  DEVSECOPS PROJECT</a:t>
             </a:r>
           </a:p>
         </p:txBody>
@@ -4870,7 +4870,7 @@
               </a:defRPr>
             </a:pPr>
             <a:r>
-              <a:t>RESOLVEDESK  /  DEVSECOPS PROJECT</a:t>
+              <a:t>CAMPUSDESK  /  DEVSECOPS PROJECT</a:t>
             </a:r>
           </a:p>
         </p:txBody>
@@ -5508,7 +5508,7 @@
               </a:defRPr>
             </a:pPr>
             <a:r>
-              <a:t>RESOLVEDESK  /  DEVSECOPS PROJECT</a:t>
+              <a:t>CAMPUSDESK  /  DEVSECOPS PROJECT</a:t>
             </a:r>
           </a:p>
         </p:txBody>
@@ -5966,7 +5966,7 @@
               </a:defRPr>
             </a:pPr>
             <a:r>
-              <a:t>RESOLVEDESK  /  DEVSECOPS PROJECT</a:t>
+              <a:t>CAMPUSDESK  /  DEVSECOPS PROJECT</a:t>
             </a:r>
           </a:p>
         </p:txBody>
@@ -6172,7 +6172,7 @@
               </a:defRPr>
             </a:pPr>
             <a:r>
-              <a:t>VPC spans two availability zones, with public and private subnets.</a:t>
+              <a:t>Shared VPC spans two availability zones; CampusDesk has its own Kubernetes namespace.</a:t>
             </a:r>
           </a:p>
         </p:txBody>
@@ -6244,7 +6244,7 @@
               </a:defRPr>
             </a:pPr>
             <a:r>
-              <a:t>EKS worker nodes use private subnets; a NAT gateway provides outbound access.</a:t>
+              <a:t>Temporary EKS workers use public subnets after the account Elastic IP quota blocked NAT creation.</a:t>
             </a:r>
           </a:p>
         </p:txBody>
@@ -6316,7 +6316,7 @@
               </a:defRPr>
             </a:pPr>
             <a:r>
-              <a:t>The Kubernetes API public endpoint is restricted to explicit operator CIDRs.</a:t>
+              <a:t>Security groups permit no public inbound access; the Kubernetes API is limited to the operator /32.</a:t>
             </a:r>
           </a:p>
         </p:txBody>
@@ -6460,7 +6460,7 @@
               </a:defRPr>
             </a:pPr>
             <a:r>
-              <a:t>Capture plan/apply and AWS proof, then destroy temporary billable resources.</a:t>
+              <a:t>Capture the recovery and deployment proof, then destroy the shared temporary resources.</a:t>
             </a:r>
           </a:p>
         </p:txBody>
@@ -6496,7 +6496,7 @@
               </a:defRPr>
             </a:pPr>
             <a:r>
-              <a:t>RESOLVEDESK  /  DEVSECOPS PROJECT</a:t>
+              <a:t>CAMPUSDESK  /  DEVSECOPS PROJECT</a:t>
             </a:r>
           </a:p>
         </p:txBody>
@@ -7026,7 +7026,7 @@
               </a:defRPr>
             </a:pPr>
             <a:r>
-              <a:t>RESOLVEDESK  /  DEVSECOPS PROJECT</a:t>
+              <a:t>CAMPUSDESK  /  DEVSECOPS PROJECT</a:t>
             </a:r>
           </a:p>
         </p:txBody>
@@ -7556,7 +7556,7 @@
               </a:defRPr>
             </a:pPr>
             <a:r>
-              <a:t>RESOLVEDESK  /  DEVSECOPS PROJECT</a:t>
+              <a:t>CAMPUSDESK  /  DEVSECOPS PROJECT</a:t>
             </a:r>
           </a:p>
         </p:txBody>
@@ -8086,7 +8086,7 @@
               </a:defRPr>
             </a:pPr>
             <a:r>
-              <a:t>RESOLVEDESK  /  DEVSECOPS PROJECT</a:t>
+              <a:t>CAMPUSDESK  /  DEVSECOPS PROJECT</a:t>
             </a:r>
           </a:p>
         </p:txBody>

</xml_diff>

<commit_message>
Add campus-specific final deck and exact printable demo script
</commit_message>
<xml_diff>
--- a/demo/presentation.pptx
+++ b/demo/presentation.pptx
@@ -3130,13 +3130,13 @@
             <a:pPr>
               <a:defRPr sz="1200" b="1">
                 <a:solidFill>
-                  <a:srgbClr val="087F8C"/>
-                </a:solidFill>
-                <a:latin typeface="Aptos"/>
-              </a:defRPr>
-            </a:pPr>
-            <a:r>
-              <a:t>A CAMPUS IT HELPDESK APPLICATION WITH A REPRODUCIBLE DEVSECOPS DELIVERY PATH</a:t>
+                  <a:srgbClr val="6554A4"/>
+                </a:solidFill>
+                <a:latin typeface="Aptos"/>
+              </a:defRPr>
+            </a:pPr>
+            <a:r>
+              <a:t>ARYAN / AJ5831A / CAMPUS IT DEMONSTRATION</a:t>
             </a:r>
           </a:p>
         </p:txBody>
@@ -3172,7 +3172,7 @@
               </a:defRPr>
             </a:pPr>
             <a:r>
-              <a:t>CampusDesk</a:t>
+              <a:t>CampusDesk: support across campus</a:t>
             </a:r>
           </a:p>
         </p:txBody>
@@ -3202,7 +3202,7 @@
             <a:pPr>
               <a:defRPr sz="1300" b="1">
                 <a:solidFill>
-                  <a:srgbClr val="087F8C"/>
+                  <a:srgbClr val="6554A4"/>
                 </a:solidFill>
                 <a:latin typeface="Aptos"/>
               </a:defRPr>
@@ -3244,7 +3244,7 @@
               </a:defRPr>
             </a:pPr>
             <a:r>
-              <a:t>Create, assign, prioritize and resolve support tickets.</a:t>
+              <a:t>Track classroom, lab and account incidents with a required campus location.</a:t>
             </a:r>
           </a:p>
         </p:txBody>
@@ -3274,7 +3274,7 @@
             <a:pPr>
               <a:defRPr sz="1300" b="1">
                 <a:solidFill>
-                  <a:srgbClr val="087F8C"/>
+                  <a:srgbClr val="6554A4"/>
                 </a:solidFill>
                 <a:latin typeface="Aptos"/>
               </a:defRPr>
@@ -3316,7 +3316,7 @@
               </a:defRPr>
             </a:pPr>
             <a:r>
-              <a:t>React interface, FastAPI services and persistent PostgreSQL storage.</a:t>
+              <a:t>Classify requests as hardware, software, network, account or other.</a:t>
             </a:r>
           </a:p>
         </p:txBody>
@@ -3346,7 +3346,7 @@
             <a:pPr>
               <a:defRPr sz="1300" b="1">
                 <a:solidFill>
-                  <a:srgbClr val="087F8C"/>
+                  <a:srgbClr val="6554A4"/>
                 </a:solidFill>
                 <a:latin typeface="Aptos"/>
               </a:defRPr>
@@ -3388,7 +3388,7 @@
               </a:defRPr>
             </a:pPr>
             <a:r>
-              <a:t>Prepared for Aryan (AJ5831A). Shared ResolveDesk foundation is credited; campus fields add a distinct workflow.</a:t>
+              <a:t>Shared ResolveDesk foundation and AI assistance are credited explicitly.</a:t>
             </a:r>
           </a:p>
         </p:txBody>
@@ -3516,13 +3516,13 @@
             <a:pPr>
               <a:defRPr sz="1200" b="1">
                 <a:solidFill>
-                  <a:srgbClr val="087F8C"/>
-                </a:solidFill>
-                <a:latin typeface="Aptos"/>
-              </a:defRPr>
-            </a:pPr>
-            <a:r>
-              <a:t>WHAT IS VERIFIED, AND WHAT STILL NEEDS PROOF</a:t>
+                  <a:srgbClr val="6554A4"/>
+                </a:solidFill>
+                <a:latin typeface="Aptos"/>
+              </a:defRPr>
+            </a:pPr>
+            <a:r>
+              <a:t>FINAL RESULTS AND LIMITS</a:t>
             </a:r>
           </a:p>
         </p:txBody>
@@ -3558,7 +3558,7 @@
               </a:defRPr>
             </a:pPr>
             <a:r>
-              <a:t>Evidence and lessons</a:t>
+              <a:t>Delivery finished with a cleanup audit</a:t>
             </a:r>
           </a:p>
         </p:txBody>
@@ -3588,7 +3588,7 @@
             <a:pPr>
               <a:defRPr sz="1300" b="1">
                 <a:solidFill>
-                  <a:srgbClr val="087F8C"/>
+                  <a:srgbClr val="6554A4"/>
                 </a:solidFill>
                 <a:latin typeface="Aptos"/>
               </a:defRPr>
@@ -3630,7 +3630,7 @@
               </a:defRPr>
             </a:pPr>
             <a:r>
-              <a:t>Verified: 31 isolated backend tests, including validation, CRUD, readiness and migration waiting.</a:t>
+              <a:t>31 backend tests, four frontend tests, browser/mobile checks and PostgreSQL smoke passed.</a:t>
             </a:r>
           </a:p>
         </p:txBody>
@@ -3660,7 +3660,7 @@
             <a:pPr>
               <a:defRPr sz="1300" b="1">
                 <a:solidFill>
-                  <a:srgbClr val="087F8C"/>
+                  <a:srgbClr val="6554A4"/>
                 </a:solidFill>
                 <a:latin typeface="Aptos"/>
               </a:defRPr>
@@ -3702,7 +3702,7 @@
               </a:defRPr>
             </a:pPr>
             <a:r>
-              <a:t>Campus variant adds category and location validation, search, forms and a dedicated migration.</a:t>
+              <a:t>A ten-slide deck and a recorded 11m38s walkthrough document the delivery.</a:t>
             </a:r>
           </a:p>
         </p:txBody>
@@ -3732,7 +3732,7 @@
             <a:pPr>
               <a:defRPr sz="1300" b="1">
                 <a:solidFill>
-                  <a:srgbClr val="087F8C"/>
+                  <a:srgbClr val="6554A4"/>
                 </a:solidFill>
                 <a:latin typeface="Aptos"/>
               </a:defRPr>
@@ -3774,7 +3774,7 @@
               </a:defRPr>
             </a:pPr>
             <a:r>
-              <a:t>Local PostgreSQL CRUD and restart persistence passed. Cloud runtime evidence is recorded separately.</a:t>
+              <a:t>Shared Terraform destroy removed 59 resources; all 11 scoped cleanup checks passed.</a:t>
             </a:r>
           </a:p>
         </p:txBody>
@@ -3804,7 +3804,7 @@
             <a:pPr>
               <a:defRPr sz="1300" b="1">
                 <a:solidFill>
-                  <a:srgbClr val="087F8C"/>
+                  <a:srgbClr val="6554A4"/>
                 </a:solidFill>
                 <a:latin typeface="Aptos"/>
               </a:defRPr>
@@ -3846,7 +3846,7 @@
               </a:defRPr>
             </a:pPr>
             <a:r>
-              <a:t>Keep test results, deployed state and teardown proof separate; none implies the others.</a:t>
+              <a:t>The owned KMS key is PendingDeletion until 15 November 2026 under AWS rules.</a:t>
             </a:r>
           </a:p>
         </p:txBody>
@@ -3876,7 +3876,7 @@
             <a:pPr>
               <a:defRPr sz="1300" b="1">
                 <a:solidFill>
-                  <a:srgbClr val="087F8C"/>
+                  <a:srgbClr val="6554A4"/>
                 </a:solidFill>
                 <a:latin typeface="Aptos"/>
               </a:defRPr>
@@ -3918,7 +3918,7 @@
               </a:defRPr>
             </a:pPr>
             <a:r>
-              <a:t>The demo has no authentication and uses a single PostgreSQL instance; production needs access control and a recovery plan.</a:t>
+              <a:t>Local demo remains available. Production would need authentication, backups and recovery planning.</a:t>
             </a:r>
           </a:p>
         </p:txBody>
@@ -4046,13 +4046,13 @@
             <a:pPr>
               <a:defRPr sz="1200" b="1">
                 <a:solidFill>
-                  <a:srgbClr val="087F8C"/>
-                </a:solidFill>
-                <a:latin typeface="Aptos"/>
-              </a:defRPr>
-            </a:pPr>
-            <a:r>
-              <a:t>PROJECT OVERVIEW</a:t>
+                  <a:srgbClr val="6554A4"/>
+                </a:solidFill>
+                <a:latin typeface="Aptos"/>
+              </a:defRPr>
+            </a:pPr>
+            <a:r>
+              <a:t>A DISTINCT CAMPUS WORKFLOW</a:t>
             </a:r>
           </a:p>
         </p:txBody>
@@ -4088,7 +4088,7 @@
               </a:defRPr>
             </a:pPr>
             <a:r>
-              <a:t>A small workflow, implemented end to end</a:t>
+              <a:t>From a lab incident to a resolution</a:t>
             </a:r>
           </a:p>
         </p:txBody>
@@ -4118,7 +4118,7 @@
             <a:pPr>
               <a:defRPr sz="1300" b="1">
                 <a:solidFill>
-                  <a:srgbClr val="087F8C"/>
+                  <a:srgbClr val="6554A4"/>
                 </a:solidFill>
                 <a:latin typeface="Aptos"/>
               </a:defRPr>
@@ -4160,7 +4160,7 @@
               </a:defRPr>
             </a:pPr>
             <a:r>
-              <a:t>Requester email, category and required campus location stay with each ticket.</a:t>
+              <a:t>Example: projector loses HDMI signal in Science block, Lab 301.</a:t>
             </a:r>
           </a:p>
         </p:txBody>
@@ -4190,7 +4190,7 @@
             <a:pPr>
               <a:defRPr sz="1300" b="1">
                 <a:solidFill>
-                  <a:srgbClr val="087F8C"/>
+                  <a:srgbClr val="6554A4"/>
                 </a:solidFill>
                 <a:latin typeface="Aptos"/>
               </a:defRPr>
@@ -4232,7 +4232,7 @@
               </a:defRPr>
             </a:pPr>
             <a:r>
-              <a:t>The workflow is OPEN → IN_PROGRESS → RESOLVED; teams can reopen tickets.</a:t>
+              <a:t>Capture requester, location, category, priority and assigned support team.</a:t>
             </a:r>
           </a:p>
         </p:txBody>
@@ -4262,7 +4262,7 @@
             <a:pPr>
               <a:defRPr sz="1300" b="1">
                 <a:solidFill>
-                  <a:srgbClr val="087F8C"/>
+                  <a:srgbClr val="6554A4"/>
                 </a:solidFill>
                 <a:latin typeface="Aptos"/>
               </a:defRPr>
@@ -4304,7 +4304,7 @@
               </a:defRPr>
             </a:pPr>
             <a:r>
-              <a:t>Search and filters help triage; summary counts expose unresolved urgent work.</a:t>
+              <a:t>Move Open to In progress to Resolved; search by location or category.</a:t>
             </a:r>
           </a:p>
         </p:txBody>
@@ -4334,7 +4334,7 @@
             <a:pPr>
               <a:defRPr sz="1300" b="1">
                 <a:solidFill>
-                  <a:srgbClr val="087F8C"/>
+                  <a:srgbClr val="6554A4"/>
                 </a:solidFill>
                 <a:latin typeface="Aptos"/>
               </a:defRPr>
@@ -4376,7 +4376,7 @@
               </a:defRPr>
             </a:pPr>
             <a:r>
-              <a:t>Assumption: an internal classroom demonstration with synthetic data and no authentication.</a:t>
+              <a:t>Demonstration data is synthetic. The application has no authentication or email delivery.</a:t>
             </a:r>
           </a:p>
         </p:txBody>
@@ -4504,13 +4504,13 @@
             <a:pPr>
               <a:defRPr sz="1200" b="1">
                 <a:solidFill>
-                  <a:srgbClr val="087F8C"/>
-                </a:solidFill>
-                <a:latin typeface="Aptos"/>
-              </a:defRPr>
-            </a:pPr>
-            <a:r>
-              <a:t>TECHNOLOGY AND CODE STRUCTURE</a:t>
+                  <a:srgbClr val="6554A4"/>
+                </a:solidFill>
+                <a:latin typeface="Aptos"/>
+              </a:defRPr>
+            </a:pPr>
+            <a:r>
+              <a:t>MODULAR IMPLEMENTATION</a:t>
             </a:r>
           </a:p>
         </p:txBody>
@@ -4546,7 +4546,7 @@
               </a:defRPr>
             </a:pPr>
             <a:r>
-              <a:t>Separate responsibilities</a:t>
+              <a:t>Campus fields have their own contract</a:t>
             </a:r>
           </a:p>
         </p:txBody>
@@ -4576,7 +4576,7 @@
             <a:pPr>
               <a:defRPr sz="1300" b="1">
                 <a:solidFill>
-                  <a:srgbClr val="087F8C"/>
+                  <a:srgbClr val="6554A4"/>
                 </a:solidFill>
                 <a:latin typeface="Aptos"/>
               </a:defRPr>
@@ -4618,7 +4618,7 @@
               </a:defRPr>
             </a:pPr>
             <a:r>
-              <a:t>React + Vite: ticket workspace, forms and accessible feedback.</a:t>
+              <a:t>TicketForm and TicketTable collect and show category and location.</a:t>
             </a:r>
           </a:p>
         </p:txBody>
@@ -4648,7 +4648,7 @@
             <a:pPr>
               <a:defRPr sz="1300" b="1">
                 <a:solidFill>
-                  <a:srgbClr val="087F8C"/>
+                  <a:srgbClr val="6554A4"/>
                 </a:solidFill>
                 <a:latin typeface="Aptos"/>
               </a:defRPr>
@@ -4690,7 +4690,7 @@
               </a:defRPr>
             </a:pPr>
             <a:r>
-              <a:t>FastAPI: HTTP routes; service functions: workflow operations; Pydantic: validation.</a:t>
+              <a:t>Pydantic requires location and validates the category enum; partial updates reject nulls.</a:t>
             </a:r>
           </a:p>
         </p:txBody>
@@ -4720,7 +4720,7 @@
             <a:pPr>
               <a:defRPr sz="1300" b="1">
                 <a:solidFill>
-                  <a:srgbClr val="087F8C"/>
+                  <a:srgbClr val="6554A4"/>
                 </a:solidFill>
                 <a:latin typeface="Aptos"/>
               </a:defRPr>
@@ -4762,7 +4762,7 @@
               </a:defRPr>
             </a:pPr>
             <a:r>
-              <a:t>SQLAlchemy + PostgreSQL: storage. Alembic: explicit schema migrations.</a:t>
+              <a:t>Routes call service functions; SQLAlchemy stores the ticket in PostgreSQL.</a:t>
             </a:r>
           </a:p>
         </p:txBody>
@@ -4792,7 +4792,7 @@
             <a:pPr>
               <a:defRPr sz="1300" b="1">
                 <a:solidFill>
-                  <a:srgbClr val="087F8C"/>
+                  <a:srgbClr val="6554A4"/>
                 </a:solidFill>
                 <a:latin typeface="Aptos"/>
               </a:defRPr>
@@ -4834,7 +4834,7 @@
               </a:defRPr>
             </a:pPr>
             <a:r>
-              <a:t>Docker Compose: local integration. Helm + Kubernetes: repeatable deployment.</a:t>
+              <a:t>Migration 0003 adds campus fields without deleting existing ticket history.</a:t>
             </a:r>
           </a:p>
         </p:txBody>
@@ -4962,13 +4962,13 @@
             <a:pPr>
               <a:defRPr sz="1200" b="1">
                 <a:solidFill>
-                  <a:srgbClr val="087F8C"/>
-                </a:solidFill>
-                <a:latin typeface="Aptos"/>
-              </a:defRPr>
-            </a:pPr>
-            <a:r>
-              <a:t>ARCHITECTURE</a:t>
+                  <a:srgbClr val="6554A4"/>
+                </a:solidFill>
+                <a:latin typeface="Aptos"/>
+              </a:defRPr>
+            </a:pPr>
+            <a:r>
+              <a:t>ARCHITECTURE AND DEPLOYMENT BOUNDARIES</a:t>
             </a:r>
           </a:p>
         </p:txBody>
@@ -5004,7 +5004,7 @@
               </a:defRPr>
             </a:pPr>
             <a:r>
-              <a:t>One application, two delivery paths</a:t>
+              <a:t>One shared cluster, separate campus data</a:t>
             </a:r>
           </a:p>
         </p:txBody>
@@ -5034,7 +5034,7 @@
             <a:pPr>
               <a:defRPr sz="2200" b="1">
                 <a:solidFill>
-                  <a:srgbClr val="087F8C"/>
+                  <a:srgbClr val="6554A4"/>
                 </a:solidFill>
                 <a:latin typeface="Aptos"/>
               </a:defRPr>
@@ -5070,7 +5070,7 @@
             <a:pPr>
               <a:defRPr sz="2200" b="1">
                 <a:solidFill>
-                  <a:srgbClr val="087F8C"/>
+                  <a:srgbClr val="6554A4"/>
                 </a:solidFill>
                 <a:latin typeface="Aptos"/>
               </a:defRPr>
@@ -5106,7 +5106,7 @@
             <a:pPr>
               <a:defRPr sz="2200" b="1">
                 <a:solidFill>
-                  <a:srgbClr val="087F8C"/>
+                  <a:srgbClr val="6554A4"/>
                 </a:solidFill>
                 <a:latin typeface="Aptos"/>
               </a:defRPr>
@@ -5142,7 +5142,7 @@
             <a:pPr>
               <a:defRPr sz="2200" b="1">
                 <a:solidFill>
-                  <a:srgbClr val="087F8C"/>
+                  <a:srgbClr val="6554A4"/>
                 </a:solidFill>
                 <a:latin typeface="Aptos"/>
               </a:defRPr>
@@ -5358,7 +5358,7 @@
             <a:pPr>
               <a:defRPr sz="1300" b="1">
                 <a:solidFill>
-                  <a:srgbClr val="087F8C"/>
+                  <a:srgbClr val="6554A4"/>
                 </a:solidFill>
                 <a:latin typeface="Aptos"/>
               </a:defRPr>
@@ -5400,7 +5400,7 @@
               </a:defRPr>
             </a:pPr>
             <a:r>
-              <a:t>Local: Compose connects the same three application services.</a:t>
+              <a:t>Local Compose: browser 3002, API 8001, private PostgreSQL service.</a:t>
             </a:r>
           </a:p>
         </p:txBody>
@@ -5430,7 +5430,7 @@
             <a:pPr>
               <a:defRPr sz="1300" b="1">
                 <a:solidFill>
-                  <a:srgbClr val="087F8C"/>
+                  <a:srgbClr val="6554A4"/>
                 </a:solidFill>
                 <a:latin typeface="Aptos"/>
               </a:defRPr>
@@ -5472,7 +5472,7 @@
               </a:defRPr>
             </a:pPr>
             <a:r>
-              <a:t>AWS: Terraform creates the VPC and EKS; Helm defines the workload.</a:t>
+              <a:t>Recorded EKS: namespace campusdesk, separate Secret and persistent database.</a:t>
             </a:r>
           </a:p>
         </p:txBody>
@@ -5600,13 +5600,13 @@
             <a:pPr>
               <a:defRPr sz="1200" b="1">
                 <a:solidFill>
-                  <a:srgbClr val="087F8C"/>
-                </a:solidFill>
-                <a:latin typeface="Aptos"/>
-              </a:defRPr>
-            </a:pPr>
-            <a:r>
-              <a:t>CONTINUOUS INTEGRATION AND SECURITY</a:t>
+                  <a:srgbClr val="6554A4"/>
+                </a:solidFill>
+                <a:latin typeface="Aptos"/>
+              </a:defRPr>
+            </a:pPr>
+            <a:r>
+              <a:t>VERIFIED CONTINUOUS INTEGRATION</a:t>
             </a:r>
           </a:p>
         </p:txBody>
@@ -5642,7 +5642,7 @@
               </a:defRPr>
             </a:pPr>
             <a:r>
-              <a:t>Test before publication</a:t>
+              <a:t>A tested image reaches the registry</a:t>
             </a:r>
           </a:p>
         </p:txBody>
@@ -5672,7 +5672,7 @@
             <a:pPr>
               <a:defRPr sz="1300" b="1">
                 <a:solidFill>
-                  <a:srgbClr val="087F8C"/>
+                  <a:srgbClr val="6554A4"/>
                 </a:solidFill>
                 <a:latin typeface="Aptos"/>
               </a:defRPr>
@@ -5714,7 +5714,7 @@
               </a:defRPr>
             </a:pPr>
             <a:r>
-              <a:t>GitHub Actions runs backend tests, frontend tests and a production frontend build.</a:t>
+              <a:t>31 backend tests and four frontend tests passed; the production frontend build passed.</a:t>
             </a:r>
           </a:p>
         </p:txBody>
@@ -5744,7 +5744,7 @@
             <a:pPr>
               <a:defRPr sz="1300" b="1">
                 <a:solidFill>
-                  <a:srgbClr val="087F8C"/>
+                  <a:srgbClr val="6554A4"/>
                 </a:solidFill>
                 <a:latin typeface="Aptos"/>
               </a:defRPr>
@@ -5786,7 +5786,7 @@
               </a:defRPr>
             </a:pPr>
             <a:r>
-              <a:t>Build each image once and tag it with the source commit SHA.</a:t>
+              <a:t>Commit-SHA images passed the Trivy HIGH/CRITICAL gate before publication.</a:t>
             </a:r>
           </a:p>
         </p:txBody>
@@ -5816,7 +5816,7 @@
             <a:pPr>
               <a:defRPr sz="1300" b="1">
                 <a:solidFill>
-                  <a:srgbClr val="087F8C"/>
+                  <a:srgbClr val="6554A4"/>
                 </a:solidFill>
                 <a:latin typeface="Aptos"/>
               </a:defRPr>
@@ -5858,7 +5858,7 @@
               </a:defRPr>
             </a:pPr>
             <a:r>
-              <a:t>Trivy blocks HIGH and CRITICAL findings and preserves scan reports.</a:t>
+              <a:t>The same images passed Helm deployment and HTTP smoke checks in temporary Kind.</a:t>
             </a:r>
           </a:p>
         </p:txBody>
@@ -5888,7 +5888,7 @@
             <a:pPr>
               <a:defRPr sz="1300" b="1">
                 <a:solidFill>
-                  <a:srgbClr val="087F8C"/>
+                  <a:srgbClr val="6554A4"/>
                 </a:solidFill>
                 <a:latin typeface="Aptos"/>
               </a:defRPr>
@@ -5930,7 +5930,7 @@
               </a:defRPr>
             </a:pPr>
             <a:r>
-              <a:t>Deploy scanned images to temporary Kind, smoke-test them, then publish to GHCR.</a:t>
+              <a:t>Final published baseline CI run 38906213468 passed at commit 1bd48967.</a:t>
             </a:r>
           </a:p>
         </p:txBody>
@@ -6058,13 +6058,13 @@
             <a:pPr>
               <a:defRPr sz="1200" b="1">
                 <a:solidFill>
-                  <a:srgbClr val="087F8C"/>
-                </a:solidFill>
-                <a:latin typeface="Aptos"/>
-              </a:defRPr>
-            </a:pPr>
-            <a:r>
-              <a:t>TERRAFORM AND AWS</a:t>
+                  <a:srgbClr val="6554A4"/>
+                </a:solidFill>
+                <a:latin typeface="Aptos"/>
+              </a:defRPr>
+            </a:pPr>
+            <a:r>
+              <a:t>TERRAFORM AND THE ACTUAL AWS RESULT</a:t>
             </a:r>
           </a:p>
         </p:txBody>
@@ -6100,7 +6100,7 @@
               </a:defRPr>
             </a:pPr>
             <a:r>
-              <a:t>Make infrastructure reproducible</a:t>
+              <a:t>Quota recovery changed the network plan</a:t>
             </a:r>
           </a:p>
         </p:txBody>
@@ -6130,7 +6130,7 @@
             <a:pPr>
               <a:defRPr sz="1300" b="1">
                 <a:solidFill>
-                  <a:srgbClr val="087F8C"/>
+                  <a:srgbClr val="6554A4"/>
                 </a:solidFill>
                 <a:latin typeface="Aptos"/>
               </a:defRPr>
@@ -6172,7 +6172,7 @@
               </a:defRPr>
             </a:pPr>
             <a:r>
-              <a:t>Shared VPC spans two availability zones; CampusDesk has its own Kubernetes namespace.</a:t>
+              <a:t>The regional Elastic IP quota blocked the initial private-worker/NAT plan.</a:t>
             </a:r>
           </a:p>
         </p:txBody>
@@ -6202,7 +6202,7 @@
             <a:pPr>
               <a:defRPr sz="1300" b="1">
                 <a:solidFill>
-                  <a:srgbClr val="087F8C"/>
+                  <a:srgbClr val="6554A4"/>
                 </a:solidFill>
                 <a:latin typeface="Aptos"/>
               </a:defRPr>
@@ -6244,7 +6244,7 @@
               </a:defRPr>
             </a:pPr>
             <a:r>
-              <a:t>Temporary EKS workers use public subnets after the account Elastic IP quota blocked NAT creation.</a:t>
+              <a:t>Approved recovery used public-subnet workers with no public inbound access and API /32.</a:t>
             </a:r>
           </a:p>
         </p:txBody>
@@ -6274,7 +6274,7 @@
             <a:pPr>
               <a:defRPr sz="1300" b="1">
                 <a:solidFill>
-                  <a:srgbClr val="087F8C"/>
+                  <a:srgbClr val="6554A4"/>
                 </a:solidFill>
                 <a:latin typeface="Aptos"/>
               </a:defRPr>
@@ -6316,7 +6316,7 @@
               </a:defRPr>
             </a:pPr>
             <a:r>
-              <a:t>Security groups permit no public inbound access; the Kubernetes API is limited to the operator /32.</a:t>
+              <a:t>Replacement workers served both applications; the old failed node group delayed removal.</a:t>
             </a:r>
           </a:p>
         </p:txBody>
@@ -6346,7 +6346,7 @@
             <a:pPr>
               <a:defRPr sz="1300" b="1">
                 <a:solidFill>
-                  <a:srgbClr val="087F8C"/>
+                  <a:srgbClr val="6554A4"/>
                 </a:solidFill>
                 <a:latin typeface="Aptos"/>
               </a:defRPr>
@@ -6388,7 +6388,7 @@
               </a:defRPr>
             </a:pPr>
             <a:r>
-              <a:t>EBS CSI receives a dedicated IAM role for persistent volumes.</a:t>
+              <a:t>Recovery apply was gracefully interrupted during deletion; it was not a clean successful apply.</a:t>
             </a:r>
           </a:p>
         </p:txBody>
@@ -6396,78 +6396,6 @@
       <p:sp>
         <p:nvSpPr>
           <p:cNvPr id="12" name="TextBox 11"/>
-          <p:cNvSpPr txBox="1"/>
-          <p:nvPr/>
-        </p:nvSpPr>
-        <p:spPr>
-          <a:xfrm>
-            <a:off x="640080" y="4946904"/>
-            <a:ext cx="457200" cy="457200"/>
-          </a:xfrm>
-          <a:prstGeom prst="rect">
-            <a:avLst/>
-          </a:prstGeom>
-          <a:noFill/>
-        </p:spPr>
-        <p:txBody>
-          <a:bodyPr wrap="square">
-            <a:spAutoFit/>
-          </a:bodyPr>
-          <a:lstStyle/>
-          <a:p>
-            <a:pPr>
-              <a:defRPr sz="1300" b="1">
-                <a:solidFill>
-                  <a:srgbClr val="087F8C"/>
-                </a:solidFill>
-                <a:latin typeface="Aptos"/>
-              </a:defRPr>
-            </a:pPr>
-            <a:r>
-              <a:t>05</a:t>
-            </a:r>
-          </a:p>
-        </p:txBody>
-      </p:sp>
-      <p:sp>
-        <p:nvSpPr>
-          <p:cNvPr id="13" name="TextBox 12"/>
-          <p:cNvSpPr txBox="1"/>
-          <p:nvPr/>
-        </p:nvSpPr>
-        <p:spPr>
-          <a:xfrm>
-            <a:off x="1188720" y="4946904"/>
-            <a:ext cx="10149840" cy="722376"/>
-          </a:xfrm>
-          <a:prstGeom prst="rect">
-            <a:avLst/>
-          </a:prstGeom>
-          <a:noFill/>
-        </p:spPr>
-        <p:txBody>
-          <a:bodyPr wrap="square">
-            <a:spAutoFit/>
-          </a:bodyPr>
-          <a:lstStyle/>
-          <a:p>
-            <a:pPr>
-              <a:defRPr sz="2000" b="0">
-                <a:solidFill>
-                  <a:srgbClr val="102A43"/>
-                </a:solidFill>
-                <a:latin typeface="Aptos"/>
-              </a:defRPr>
-            </a:pPr>
-            <a:r>
-              <a:t>Capture the recovery and deployment proof, then destroy the shared temporary resources.</a:t>
-            </a:r>
-          </a:p>
-        </p:txBody>
-      </p:sp>
-      <p:sp>
-        <p:nvSpPr>
-          <p:cNvPr id="14" name="TextBox 13"/>
           <p:cNvSpPr txBox="1"/>
           <p:nvPr/>
         </p:nvSpPr>
@@ -6503,7 +6431,7 @@
       </p:sp>
       <p:sp>
         <p:nvSpPr>
-          <p:cNvPr id="15" name="TextBox 14"/>
+          <p:cNvPr id="13" name="TextBox 12"/>
           <p:cNvSpPr txBox="1"/>
           <p:nvPr/>
         </p:nvSpPr>
@@ -6588,13 +6516,13 @@
             <a:pPr>
               <a:defRPr sz="1200" b="1">
                 <a:solidFill>
-                  <a:srgbClr val="087F8C"/>
-                </a:solidFill>
-                <a:latin typeface="Aptos"/>
-              </a:defRPr>
-            </a:pPr>
-            <a:r>
-              <a:t>KUBERNETES AND HELM</a:t>
+                  <a:srgbClr val="6554A4"/>
+                </a:solidFill>
+                <a:latin typeface="Aptos"/>
+              </a:defRPr>
+            </a:pPr>
+            <a:r>
+              <a:t>KUBERNETES, STORAGE AND SCALING</a:t>
             </a:r>
           </a:p>
         </p:txBody>
@@ -6630,7 +6558,7 @@
               </a:defRPr>
             </a:pPr>
             <a:r>
-              <a:t>Deploy and recover predictably</a:t>
+              <a:t>The campus workload was verified</a:t>
             </a:r>
           </a:p>
         </p:txBody>
@@ -6660,7 +6588,7 @@
             <a:pPr>
               <a:defRPr sz="1300" b="1">
                 <a:solidFill>
-                  <a:srgbClr val="087F8C"/>
+                  <a:srgbClr val="6554A4"/>
                 </a:solidFill>
                 <a:latin typeface="Aptos"/>
               </a:defRPr>
@@ -6702,7 +6630,7 @@
               </a:defRPr>
             </a:pPr>
             <a:r>
-              <a:t>Frontend and backend Deployments use probes, resource requests and limits.</a:t>
+              <a:t>Recorded proof shows two API replicas, two frontend replicas and a completed migration Job.</a:t>
             </a:r>
           </a:p>
         </p:txBody>
@@ -6732,7 +6660,7 @@
             <a:pPr>
               <a:defRPr sz="1300" b="1">
                 <a:solidFill>
-                  <a:srgbClr val="087F8C"/>
+                  <a:srgbClr val="6554A4"/>
                 </a:solidFill>
                 <a:latin typeface="Aptos"/>
               </a:defRPr>
@@ -6774,7 +6702,7 @@
               </a:defRPr>
             </a:pPr>
             <a:r>
-              <a:t>A database StatefulSet uses persistent storage; credentials come from a Secret.</a:t>
+              <a:t>PostgreSQL used its own bound 5 GiB volume in namespace campusdesk.</a:t>
             </a:r>
           </a:p>
         </p:txBody>
@@ -6804,7 +6732,7 @@
             <a:pPr>
               <a:defRPr sz="1300" b="1">
                 <a:solidFill>
-                  <a:srgbClr val="087F8C"/>
+                  <a:srgbClr val="6554A4"/>
                 </a:solidFill>
                 <a:latin typeface="Aptos"/>
               </a:defRPr>
@@ -6846,7 +6774,7 @@
               </a:defRPr>
             </a:pPr>
             <a:r>
-              <a:t>A migration Job applies Alembic before the application is considered ready.</a:t>
+              <a:t>Readiness, liveness, resource limits and HPA were configured; metrics were available.</a:t>
             </a:r>
           </a:p>
         </p:txBody>
@@ -6876,7 +6804,7 @@
             <a:pPr>
               <a:defRPr sz="1300" b="1">
                 <a:solidFill>
-                  <a:srgbClr val="087F8C"/>
+                  <a:srgbClr val="6554A4"/>
                 </a:solidFill>
                 <a:latin typeface="Aptos"/>
               </a:defRPr>
@@ -6918,7 +6846,7 @@
               </a:defRPr>
             </a:pPr>
             <a:r>
-              <a:t>HPA adjusts backend replicas; an Ingress can provide a single application endpoint.</a:t>
+              <a:t>The cloud cluster has since been destroyed. Today use local UI and recorded cloud evidence.</a:t>
             </a:r>
           </a:p>
         </p:txBody>
@@ -6926,78 +6854,6 @@
       <p:sp>
         <p:nvSpPr>
           <p:cNvPr id="12" name="TextBox 11"/>
-          <p:cNvSpPr txBox="1"/>
-          <p:nvPr/>
-        </p:nvSpPr>
-        <p:spPr>
-          <a:xfrm>
-            <a:off x="640080" y="4946904"/>
-            <a:ext cx="457200" cy="457200"/>
-          </a:xfrm>
-          <a:prstGeom prst="rect">
-            <a:avLst/>
-          </a:prstGeom>
-          <a:noFill/>
-        </p:spPr>
-        <p:txBody>
-          <a:bodyPr wrap="square">
-            <a:spAutoFit/>
-          </a:bodyPr>
-          <a:lstStyle/>
-          <a:p>
-            <a:pPr>
-              <a:defRPr sz="1300" b="1">
-                <a:solidFill>
-                  <a:srgbClr val="087F8C"/>
-                </a:solidFill>
-                <a:latin typeface="Aptos"/>
-              </a:defRPr>
-            </a:pPr>
-            <a:r>
-              <a:t>05</a:t>
-            </a:r>
-          </a:p>
-        </p:txBody>
-      </p:sp>
-      <p:sp>
-        <p:nvSpPr>
-          <p:cNvPr id="13" name="TextBox 12"/>
-          <p:cNvSpPr txBox="1"/>
-          <p:nvPr/>
-        </p:nvSpPr>
-        <p:spPr>
-          <a:xfrm>
-            <a:off x="1188720" y="4946904"/>
-            <a:ext cx="10149840" cy="722376"/>
-          </a:xfrm>
-          <a:prstGeom prst="rect">
-            <a:avLst/>
-          </a:prstGeom>
-          <a:noFill/>
-        </p:spPr>
-        <p:txBody>
-          <a:bodyPr wrap="square">
-            <a:spAutoFit/>
-          </a:bodyPr>
-          <a:lstStyle/>
-          <a:p>
-            <a:pPr>
-              <a:defRPr sz="2000" b="0">
-                <a:solidFill>
-                  <a:srgbClr val="102A43"/>
-                </a:solidFill>
-                <a:latin typeface="Aptos"/>
-              </a:defRPr>
-            </a:pPr>
-            <a:r>
-              <a:t>Runtime evidence must show the actual pods, services, storage and health state.</a:t>
-            </a:r>
-          </a:p>
-        </p:txBody>
-      </p:sp>
-      <p:sp>
-        <p:nvSpPr>
-          <p:cNvPr id="14" name="TextBox 13"/>
           <p:cNvSpPr txBox="1"/>
           <p:nvPr/>
         </p:nvSpPr>
@@ -7033,7 +6889,7 @@
       </p:sp>
       <p:sp>
         <p:nvSpPr>
-          <p:cNvPr id="15" name="TextBox 14"/>
+          <p:cNvPr id="13" name="TextBox 12"/>
           <p:cNvSpPr txBox="1"/>
           <p:nvPr/>
         </p:nvSpPr>
@@ -7118,13 +6974,13 @@
             <a:pPr>
               <a:defRPr sz="1200" b="1">
                 <a:solidFill>
-                  <a:srgbClr val="087F8C"/>
-                </a:solidFill>
-                <a:latin typeface="Aptos"/>
-              </a:defRPr>
-            </a:pPr>
-            <a:r>
-              <a:t>ARGOCD AND GITOPS</a:t>
+                  <a:srgbClr val="6554A4"/>
+                </a:solidFill>
+                <a:latin typeface="Aptos"/>
+              </a:defRPr>
+            </a:pPr>
+            <a:r>
+              <a:t>ARGOCD EVIDENCE</a:t>
             </a:r>
           </a:p>
         </p:txBody>
@@ -7160,7 +7016,7 @@
               </a:defRPr>
             </a:pPr>
             <a:r>
-              <a:t>Git records the desired release</a:t>
+              <a:t>GitOps was more than a YAML file</a:t>
             </a:r>
           </a:p>
         </p:txBody>
@@ -7190,7 +7046,7 @@
             <a:pPr>
               <a:defRPr sz="1300" b="1">
                 <a:solidFill>
-                  <a:srgbClr val="087F8C"/>
+                  <a:srgbClr val="6554A4"/>
                 </a:solidFill>
                 <a:latin typeface="Aptos"/>
               </a:defRPr>
@@ -7232,7 +7088,7 @@
               </a:defRPr>
             </a:pPr>
             <a:r>
-              <a:t>ArgoCD reads the Helm chart and release values from Git.</a:t>
+              <a:t>ArgoCD tracked the CampusDesk repository and Helm release values.</a:t>
             </a:r>
           </a:p>
         </p:txBody>
@@ -7262,7 +7118,7 @@
             <a:pPr>
               <a:defRPr sz="1300" b="1">
                 <a:solidFill>
-                  <a:srgbClr val="087F8C"/>
+                  <a:srgbClr val="6554A4"/>
                 </a:solidFill>
                 <a:latin typeface="Aptos"/>
               </a:defRPr>
@@ -7304,7 +7160,7 @@
               </a:defRPr>
             </a:pPr>
             <a:r>
-              <a:t>Commit-SHA image tags connect a deployed release to its tested source.</a:t>
+              <a:t>The recorded application reached Synced, Healthy and Succeeded.</a:t>
             </a:r>
           </a:p>
         </p:txBody>
@@ -7334,7 +7190,7 @@
             <a:pPr>
               <a:defRPr sz="1300" b="1">
                 <a:solidFill>
-                  <a:srgbClr val="087F8C"/>
+                  <a:srgbClr val="6554A4"/>
                 </a:solidFill>
                 <a:latin typeface="Aptos"/>
               </a:defRPr>
@@ -7376,7 +7232,7 @@
               </a:defRPr>
             </a:pPr>
             <a:r>
-              <a:t>A values change updates the desired state; ArgoCD reconciles the cluster.</a:t>
+              <a:t>Deployed images used the verified 9a7a184 commit tag; later docs commits kept that release.</a:t>
             </a:r>
           </a:p>
         </p:txBody>
@@ -7406,7 +7262,7 @@
             <a:pPr>
               <a:defRPr sz="1300" b="1">
                 <a:solidFill>
-                  <a:srgbClr val="087F8C"/>
+                  <a:srgbClr val="6554A4"/>
                 </a:solidFill>
                 <a:latin typeface="Aptos"/>
               </a:defRPr>
@@ -7448,7 +7304,7 @@
               </a:defRPr>
             </a:pPr>
             <a:r>
-              <a:t>Show Synced and Healthy states, then demonstrate a controlled release update.</a:t>
+              <a:t>Backend replica drift is ignored so ArgoCD does not fight the HPA.</a:t>
             </a:r>
           </a:p>
         </p:txBody>
@@ -7456,78 +7312,6 @@
       <p:sp>
         <p:nvSpPr>
           <p:cNvPr id="12" name="TextBox 11"/>
-          <p:cNvSpPr txBox="1"/>
-          <p:nvPr/>
-        </p:nvSpPr>
-        <p:spPr>
-          <a:xfrm>
-            <a:off x="640080" y="4946904"/>
-            <a:ext cx="457200" cy="457200"/>
-          </a:xfrm>
-          <a:prstGeom prst="rect">
-            <a:avLst/>
-          </a:prstGeom>
-          <a:noFill/>
-        </p:spPr>
-        <p:txBody>
-          <a:bodyPr wrap="square">
-            <a:spAutoFit/>
-          </a:bodyPr>
-          <a:lstStyle/>
-          <a:p>
-            <a:pPr>
-              <a:defRPr sz="1300" b="1">
-                <a:solidFill>
-                  <a:srgbClr val="087F8C"/>
-                </a:solidFill>
-                <a:latin typeface="Aptos"/>
-              </a:defRPr>
-            </a:pPr>
-            <a:r>
-              <a:t>05</a:t>
-            </a:r>
-          </a:p>
-        </p:txBody>
-      </p:sp>
-      <p:sp>
-        <p:nvSpPr>
-          <p:cNvPr id="13" name="TextBox 12"/>
-          <p:cNvSpPr txBox="1"/>
-          <p:nvPr/>
-        </p:nvSpPr>
-        <p:spPr>
-          <a:xfrm>
-            <a:off x="1188720" y="4946904"/>
-            <a:ext cx="10149840" cy="722376"/>
-          </a:xfrm>
-          <a:prstGeom prst="rect">
-            <a:avLst/>
-          </a:prstGeom>
-          <a:noFill/>
-        </p:spPr>
-        <p:txBody>
-          <a:bodyPr wrap="square">
-            <a:spAutoFit/>
-          </a:bodyPr>
-          <a:lstStyle/>
-          <a:p>
-            <a:pPr>
-              <a:defRPr sz="2000" b="0">
-                <a:solidFill>
-                  <a:srgbClr val="102A43"/>
-                </a:solidFill>
-                <a:latin typeface="Aptos"/>
-              </a:defRPr>
-            </a:pPr>
-            <a:r>
-              <a:t>A configured Application alone is not proof of a successful synchronization.</a:t>
-            </a:r>
-          </a:p>
-        </p:txBody>
-      </p:sp>
-      <p:sp>
-        <p:nvSpPr>
-          <p:cNvPr id="14" name="TextBox 13"/>
           <p:cNvSpPr txBox="1"/>
           <p:nvPr/>
         </p:nvSpPr>
@@ -7563,7 +7347,7 @@
       </p:sp>
       <p:sp>
         <p:nvSpPr>
-          <p:cNvPr id="15" name="TextBox 14"/>
+          <p:cNvPr id="13" name="TextBox 12"/>
           <p:cNvSpPr txBox="1"/>
           <p:nvPr/>
         </p:nvSpPr>
@@ -7648,13 +7432,13 @@
             <a:pPr>
               <a:defRPr sz="1200" b="1">
                 <a:solidFill>
-                  <a:srgbClr val="087F8C"/>
-                </a:solidFill>
-                <a:latin typeface="Aptos"/>
-              </a:defRPr>
-            </a:pPr>
-            <a:r>
-              <a:t>PROMETHEUS AND GRAFANA</a:t>
+                  <a:srgbClr val="6554A4"/>
+                </a:solidFill>
+                <a:latin typeface="Aptos"/>
+              </a:defRPr>
+            </a:pPr>
+            <a:r>
+              <a:t>PROMETHEUS AND GRAFANA EVIDENCE</a:t>
             </a:r>
           </a:p>
         </p:txBody>
@@ -7690,7 +7474,7 @@
               </a:defRPr>
             </a:pPr>
             <a:r>
-              <a:t>Observe behavior, not just containers</a:t>
+              <a:t>Check actual metrics, not assumptions</a:t>
             </a:r>
           </a:p>
         </p:txBody>
@@ -7720,7 +7504,7 @@
             <a:pPr>
               <a:defRPr sz="1300" b="1">
                 <a:solidFill>
-                  <a:srgbClr val="087F8C"/>
+                  <a:srgbClr val="6554A4"/>
                 </a:solidFill>
                 <a:latin typeface="Aptos"/>
               </a:defRPr>
@@ -7762,7 +7546,7 @@
               </a:defRPr>
             </a:pPr>
             <a:r>
-              <a:t>/health reports process liveness; /ready checks access to the migrated database.</a:t>
+              <a:t>Recorded Prometheus proof shows both CampusDesk API endpoints UP.</a:t>
             </a:r>
           </a:p>
         </p:txBody>
@@ -7792,7 +7576,7 @@
             <a:pPr>
               <a:defRPr sz="1300" b="1">
                 <a:solidFill>
-                  <a:srgbClr val="087F8C"/>
+                  <a:srgbClr val="6554A4"/>
                 </a:solidFill>
                 <a:latin typeface="Aptos"/>
               </a:defRPr>
@@ -7834,7 +7618,7 @@
               </a:defRPr>
             </a:pPr>
             <a:r>
-              <a:t>/metrics exposes HTTP request counts, duration and status metrics.</a:t>
+              <a:t>The campus dashboard contains real request-rate and p95-latency samples.</a:t>
             </a:r>
           </a:p>
         </p:txBody>
@@ -7864,7 +7648,7 @@
             <a:pPr>
               <a:defRPr sz="1300" b="1">
                 <a:solidFill>
-                  <a:srgbClr val="087F8C"/>
+                  <a:srgbClr val="6554A4"/>
                 </a:solidFill>
                 <a:latin typeface="Aptos"/>
               </a:defRPr>
@@ -7906,7 +7690,7 @@
               </a:defRPr>
             </a:pPr>
             <a:r>
-              <a:t>A ServiceMonitor connects the API to Prometheus; verify its target is UP.</a:t>
+              <a:t>The error panel had no matching series; that was not presented as a measured zero.</a:t>
             </a:r>
           </a:p>
         </p:txBody>
@@ -7936,7 +7720,7 @@
             <a:pPr>
               <a:defRPr sz="1300" b="1">
                 <a:solidFill>
-                  <a:srgbClr val="087F8C"/>
+                  <a:srgbClr val="6554A4"/>
                 </a:solidFill>
                 <a:latin typeface="Aptos"/>
               </a:defRPr>
@@ -7978,7 +7762,7 @@
               </a:defRPr>
             </a:pPr>
             <a:r>
-              <a:t>Grafana displays request rate, p95 latency and server errors.</a:t>
+              <a:t>Grafana authentication was refreshed after a monitoring pod restart.</a:t>
             </a:r>
           </a:p>
         </p:txBody>
@@ -7986,78 +7770,6 @@
       <p:sp>
         <p:nvSpPr>
           <p:cNvPr id="12" name="TextBox 11"/>
-          <p:cNvSpPr txBox="1"/>
-          <p:nvPr/>
-        </p:nvSpPr>
-        <p:spPr>
-          <a:xfrm>
-            <a:off x="640080" y="4946904"/>
-            <a:ext cx="457200" cy="457200"/>
-          </a:xfrm>
-          <a:prstGeom prst="rect">
-            <a:avLst/>
-          </a:prstGeom>
-          <a:noFill/>
-        </p:spPr>
-        <p:txBody>
-          <a:bodyPr wrap="square">
-            <a:spAutoFit/>
-          </a:bodyPr>
-          <a:lstStyle/>
-          <a:p>
-            <a:pPr>
-              <a:defRPr sz="1300" b="1">
-                <a:solidFill>
-                  <a:srgbClr val="087F8C"/>
-                </a:solidFill>
-                <a:latin typeface="Aptos"/>
-              </a:defRPr>
-            </a:pPr>
-            <a:r>
-              <a:t>05</a:t>
-            </a:r>
-          </a:p>
-        </p:txBody>
-      </p:sp>
-      <p:sp>
-        <p:nvSpPr>
-          <p:cNvPr id="13" name="TextBox 12"/>
-          <p:cNvSpPr txBox="1"/>
-          <p:nvPr/>
-        </p:nvSpPr>
-        <p:spPr>
-          <a:xfrm>
-            <a:off x="1188720" y="4946904"/>
-            <a:ext cx="10149840" cy="722376"/>
-          </a:xfrm>
-          <a:prstGeom prst="rect">
-            <a:avLst/>
-          </a:prstGeom>
-          <a:noFill/>
-        </p:spPr>
-        <p:txBody>
-          <a:bodyPr wrap="square">
-            <a:spAutoFit/>
-          </a:bodyPr>
-          <a:lstStyle/>
-          <a:p>
-            <a:pPr>
-              <a:defRPr sz="2000" b="0">
-                <a:solidFill>
-                  <a:srgbClr val="102A43"/>
-                </a:solidFill>
-                <a:latin typeface="Aptos"/>
-              </a:defRPr>
-            </a:pPr>
-            <a:r>
-              <a:t>Generate traffic and allow scrape intervals before recording the dashboard.</a:t>
-            </a:r>
-          </a:p>
-        </p:txBody>
-      </p:sp>
-      <p:sp>
-        <p:nvSpPr>
-          <p:cNvPr id="14" name="TextBox 13"/>
           <p:cNvSpPr txBox="1"/>
           <p:nvPr/>
         </p:nvSpPr>
@@ -8093,7 +7805,7 @@
       </p:sp>
       <p:sp>
         <p:nvSpPr>
-          <p:cNvPr id="15" name="TextBox 14"/>
+          <p:cNvPr id="13" name="TextBox 12"/>
           <p:cNvSpPr txBox="1"/>
           <p:nvPr/>
         </p:nvSpPr>

</xml_diff>